<commit_message>
#1 updates following review
</commit_message>
<xml_diff>
--- a/PRE_SM11.pptx
+++ b/PRE_SM11.pptx
@@ -12075,7 +12075,7 @@
             <a:tbl>
               <a:tblPr>
                 <a:noFill/>
-                <a:tableStyleId>{BC84F581-A8CD-4CCD-83CA-47A092EE059C}</a:tableStyleId>
+                <a:tableStyleId>{ECED062A-D991-45DC-B9B7-9121D6024991}</a:tableStyleId>
               </a:tblPr>
               <a:tblGrid>
                 <a:gridCol w="1894625"/>
@@ -14868,7 +14868,7 @@
             <a:tbl>
               <a:tblPr>
                 <a:noFill/>
-                <a:tableStyleId>{BC84F581-A8CD-4CCD-83CA-47A092EE059C}</a:tableStyleId>
+                <a:tableStyleId>{ECED062A-D991-45DC-B9B7-9121D6024991}</a:tableStyleId>
               </a:tblPr>
               <a:tblGrid>
                 <a:gridCol w="1958075"/>
@@ -16655,7 +16655,7 @@
             <a:tbl>
               <a:tblPr>
                 <a:noFill/>
-                <a:tableStyleId>{BC84F581-A8CD-4CCD-83CA-47A092EE059C}</a:tableStyleId>
+                <a:tableStyleId>{ECED062A-D991-45DC-B9B7-9121D6024991}</a:tableStyleId>
               </a:tblPr>
               <a:tblGrid>
                 <a:gridCol w="1771100"/>
@@ -17031,7 +17031,19 @@
                           <a:cs typeface="Roche Sans"/>
                           <a:sym typeface="Roche Sans"/>
                         </a:rPr>
-                        <a:t> functions dynamically generates custom </a:t>
+                        <a:t> functions dynamically generates </a:t>
+                      </a:r>
+                      <a:r>
+                        <a:rPr i="1" lang="en" spc="8">
+                          <a:highlight>
+                            <a:srgbClr val="FFFFFF"/>
+                          </a:highlight>
+                          <a:latin typeface="Roche Sans"/>
+                          <a:ea typeface="Roche Sans"/>
+                          <a:cs typeface="Roche Sans"/>
+                          <a:sym typeface="Roche Sans"/>
+                        </a:rPr>
+                        <a:t>custom </a:t>
                       </a:r>
                       <a:r>
                         <a:rPr lang="en" spc="8">
@@ -17058,25 +17070,10 @@
                           <a:cs typeface="Roche Sans"/>
                           <a:sym typeface="Roche Sans"/>
                         </a:rPr>
-                        <a:t> script by choosing chunks based on user input, then  </a:t>
+                        <a:t> script by choosing chunks based on user input, this custom script is automatically executed to serve </a:t>
                       </a:r>
                       <a:r>
-                        <a:rPr lang="en" spc="8">
-                          <a:solidFill>
-                            <a:srgbClr val="188038"/>
-                          </a:solidFill>
-                          <a:highlight>
-                            <a:srgbClr val="FFFFFF"/>
-                          </a:highlight>
-                          <a:latin typeface="Roboto Mono"/>
-                          <a:ea typeface="Roboto Mono"/>
-                          <a:cs typeface="Roboto Mono"/>
-                          <a:sym typeface="Roboto Mono"/>
-                        </a:rPr>
-                        <a:t>create_adsl.R</a:t>
-                      </a:r>
-                      <a:r>
-                        <a:rPr lang="en" spc="8">
+                        <a:rPr i="1" lang="en" spc="8">
                           <a:highlight>
                             <a:srgbClr val="FFFFFF"/>
                           </a:highlight>
@@ -17085,7 +17082,7 @@
                           <a:cs typeface="Roche Sans"/>
                           <a:sym typeface="Roche Sans"/>
                         </a:rPr>
-                        <a:t> scripts is automatically executed to serve custom </a:t>
+                        <a:t>custom </a:t>
                       </a:r>
                       <a:r>
                         <a:rPr lang="en" spc="8">
@@ -17690,7 +17687,7 @@
         <p:spPr>
           <a:xfrm>
             <a:off x="306825" y="1063150"/>
-            <a:ext cx="8494200" cy="2610900"/>
+            <a:ext cx="8768400" cy="2610900"/>
           </a:xfrm>
           <a:prstGeom prst="rect">
             <a:avLst/>
@@ -17859,7 +17856,23 @@
             </a:pPr>
             <a:r>
               <a:rPr lang="en"/>
-              <a:t>&lt;Maybe add some metric to measure success?&gt;</a:t>
+              <a:t>Initial script creation times for our users have </a:t>
+            </a:r>
+            <a:r>
+              <a:rPr b="1" lang="en">
+                <a:solidFill>
+                  <a:schemeClr val="dk1"/>
+                </a:solidFill>
+                <a:latin typeface="Roche Sans"/>
+                <a:ea typeface="Roche Sans"/>
+                <a:cs typeface="Roche Sans"/>
+                <a:sym typeface="Roche Sans"/>
+              </a:rPr>
+              <a:t>halved</a:t>
+            </a:r>
+            <a:r>
+              <a:rPr lang="en"/>
+              <a:t>, as has the maintenance load for {admiralroche} developers. </a:t>
             </a:r>
             <a:endParaRPr/>
           </a:p>
@@ -17921,7 +17934,7 @@
             </a:pPr>
             <a:r>
               <a:rPr lang="en"/>
-              <a:t>AI agents should be able to read specifications and make selections for users.</a:t>
+              <a:t>AI agents could read specifications and make selections for users.</a:t>
             </a:r>
             <a:endParaRPr/>
           </a:p>

</xml_diff>